<commit_message>
Add language-specific scale images
</commit_message>
<xml_diff>
--- a/public/images/TQR.pptx
+++ b/public/images/TQR.pptx
@@ -8,6 +8,7 @@
     <p:sldId id="256" r:id="rId2"/>
     <p:sldId id="257" r:id="rId3"/>
     <p:sldId id="258" r:id="rId4"/>
+    <p:sldId id="259" r:id="rId5"/>
   </p:sldIdLst>
   <p:sldSz cx="6858000" cy="9906000" type="A4"/>
   <p:notesSz cx="6858000" cy="9144000"/>
@@ -114,20 +115,12 @@
 </p:presentation>
 </file>
 
-<file path=ppt/revisionInfo.xml><?xml version="1.0" encoding="utf-8"?>
-<p1510:revInfo xmlns:a="http://schemas.openxmlformats.org/drawingml/2006/main" xmlns:r="http://schemas.openxmlformats.org/officeDocument/2006/relationships" xmlns:p1510="http://schemas.microsoft.com/office/powerpoint/2015/10/main">
-  <p1510:revLst>
-    <p1510:client id="{816E1673-4A03-41D5-B856-6D0BAA978D80}" v="4" dt="2026-10-06T07:24:07.776"/>
-  </p1510:revLst>
-</p1510:revInfo>
-</file>
-
 <file path=ppt/changesInfos/changesInfo1.xml><?xml version="1.0" encoding="utf-8"?>
 <pc:chgInfo xmlns:a="http://schemas.openxmlformats.org/drawingml/2006/main" xmlns:r="http://schemas.openxmlformats.org/officeDocument/2006/relationships" xmlns:ac="http://schemas.microsoft.com/office/drawing/2013/main/command" xmlns:pc="http://schemas.microsoft.com/office/powerpoint/2013/main/command">
   <pc:docChgLst>
     <pc:chgData name="Roberto Modena" userId="7ff1dab3-0c19-473f-9c29-1dab44874c84" providerId="ADAL" clId="{113580EF-F499-4883-AAEE-AE7FAB5F14F6}"/>
     <pc:docChg chg="undo custSel addSld modSld">
-      <pc:chgData name="Roberto Modena" userId="7ff1dab3-0c19-473f-9c29-1dab44874c84" providerId="ADAL" clId="{113580EF-F499-4883-AAEE-AE7FAB5F14F6}" dt="2026-10-06T07:31:59.166" v="222" actId="14100"/>
+      <pc:chgData name="Roberto Modena" userId="7ff1dab3-0c19-473f-9c29-1dab44874c84" providerId="ADAL" clId="{113580EF-F499-4883-AAEE-AE7FAB5F14F6}" dt="2026-10-07T15:08:47.165" v="229" actId="14100"/>
       <pc:docMkLst>
         <pc:docMk/>
       </pc:docMkLst>
@@ -248,6 +241,29 @@
           </ac:picMkLst>
         </pc:picChg>
       </pc:sldChg>
+      <pc:sldChg chg="addSp delSp modSp add mod">
+        <pc:chgData name="Roberto Modena" userId="7ff1dab3-0c19-473f-9c29-1dab44874c84" providerId="ADAL" clId="{113580EF-F499-4883-AAEE-AE7FAB5F14F6}" dt="2026-10-07T15:08:47.165" v="229" actId="14100"/>
+        <pc:sldMkLst>
+          <pc:docMk/>
+          <pc:sldMk cId="1469452970" sldId="259"/>
+        </pc:sldMkLst>
+        <pc:picChg chg="add mod">
+          <ac:chgData name="Roberto Modena" userId="7ff1dab3-0c19-473f-9c29-1dab44874c84" providerId="ADAL" clId="{113580EF-F499-4883-AAEE-AE7FAB5F14F6}" dt="2026-10-07T15:08:47.165" v="229" actId="14100"/>
+          <ac:picMkLst>
+            <pc:docMk/>
+            <pc:sldMk cId="1469452970" sldId="259"/>
+            <ac:picMk id="3" creationId="{F251D190-2DFB-2C1B-41F6-CE31AB87266C}"/>
+          </ac:picMkLst>
+        </pc:picChg>
+        <pc:picChg chg="del">
+          <ac:chgData name="Roberto Modena" userId="7ff1dab3-0c19-473f-9c29-1dab44874c84" providerId="ADAL" clId="{113580EF-F499-4883-AAEE-AE7FAB5F14F6}" dt="2026-10-07T15:08:25.311" v="224" actId="478"/>
+          <ac:picMkLst>
+            <pc:docMk/>
+            <pc:sldMk cId="1469452970" sldId="259"/>
+            <ac:picMk id="5" creationId="{BCCD9C10-92F9-DA7D-D21E-7D56E4514268}"/>
+          </ac:picMkLst>
+        </pc:picChg>
+      </pc:sldChg>
     </pc:docChg>
   </pc:docChgLst>
 </pc:chgInfo>
@@ -384,7 +400,7 @@
           <a:p>
             <a:fld id="{C8414FAB-7AD7-4C12-87C1-271A81F50A84}" type="datetimeFigureOut">
               <a:rPr lang="en-US" smtClean="0"/>
-              <a:t>10/6/2026</a:t>
+              <a:t>10/7/2026</a:t>
             </a:fld>
             <a:endParaRPr lang="en-US"/>
           </a:p>
@@ -554,7 +570,7 @@
           <a:p>
             <a:fld id="{C8414FAB-7AD7-4C12-87C1-271A81F50A84}" type="datetimeFigureOut">
               <a:rPr lang="en-US" smtClean="0"/>
-              <a:t>10/6/2026</a:t>
+              <a:t>10/7/2026</a:t>
             </a:fld>
             <a:endParaRPr lang="en-US"/>
           </a:p>
@@ -734,7 +750,7 @@
           <a:p>
             <a:fld id="{C8414FAB-7AD7-4C12-87C1-271A81F50A84}" type="datetimeFigureOut">
               <a:rPr lang="en-US" smtClean="0"/>
-              <a:t>10/6/2026</a:t>
+              <a:t>10/7/2026</a:t>
             </a:fld>
             <a:endParaRPr lang="en-US"/>
           </a:p>
@@ -904,7 +920,7 @@
           <a:p>
             <a:fld id="{C8414FAB-7AD7-4C12-87C1-271A81F50A84}" type="datetimeFigureOut">
               <a:rPr lang="en-US" smtClean="0"/>
-              <a:t>10/6/2026</a:t>
+              <a:t>10/7/2026</a:t>
             </a:fld>
             <a:endParaRPr lang="en-US"/>
           </a:p>
@@ -1150,7 +1166,7 @@
           <a:p>
             <a:fld id="{C8414FAB-7AD7-4C12-87C1-271A81F50A84}" type="datetimeFigureOut">
               <a:rPr lang="en-US" smtClean="0"/>
-              <a:t>10/6/2026</a:t>
+              <a:t>10/7/2026</a:t>
             </a:fld>
             <a:endParaRPr lang="en-US"/>
           </a:p>
@@ -1382,7 +1398,7 @@
           <a:p>
             <a:fld id="{C8414FAB-7AD7-4C12-87C1-271A81F50A84}" type="datetimeFigureOut">
               <a:rPr lang="en-US" smtClean="0"/>
-              <a:t>10/6/2026</a:t>
+              <a:t>10/7/2026</a:t>
             </a:fld>
             <a:endParaRPr lang="en-US"/>
           </a:p>
@@ -1749,7 +1765,7 @@
           <a:p>
             <a:fld id="{C8414FAB-7AD7-4C12-87C1-271A81F50A84}" type="datetimeFigureOut">
               <a:rPr lang="en-US" smtClean="0"/>
-              <a:t>10/6/2026</a:t>
+              <a:t>10/7/2026</a:t>
             </a:fld>
             <a:endParaRPr lang="en-US"/>
           </a:p>
@@ -1867,7 +1883,7 @@
           <a:p>
             <a:fld id="{C8414FAB-7AD7-4C12-87C1-271A81F50A84}" type="datetimeFigureOut">
               <a:rPr lang="en-US" smtClean="0"/>
-              <a:t>10/6/2026</a:t>
+              <a:t>10/7/2026</a:t>
             </a:fld>
             <a:endParaRPr lang="en-US"/>
           </a:p>
@@ -1962,7 +1978,7 @@
           <a:p>
             <a:fld id="{C8414FAB-7AD7-4C12-87C1-271A81F50A84}" type="datetimeFigureOut">
               <a:rPr lang="en-US" smtClean="0"/>
-              <a:t>10/6/2026</a:t>
+              <a:t>10/7/2026</a:t>
             </a:fld>
             <a:endParaRPr lang="en-US"/>
           </a:p>
@@ -2239,7 +2255,7 @@
           <a:p>
             <a:fld id="{C8414FAB-7AD7-4C12-87C1-271A81F50A84}" type="datetimeFigureOut">
               <a:rPr lang="en-US" smtClean="0"/>
-              <a:t>10/6/2026</a:t>
+              <a:t>10/7/2026</a:t>
             </a:fld>
             <a:endParaRPr lang="en-US"/>
           </a:p>
@@ -2492,7 +2508,7 @@
           <a:p>
             <a:fld id="{C8414FAB-7AD7-4C12-87C1-271A81F50A84}" type="datetimeFigureOut">
               <a:rPr lang="en-US" smtClean="0"/>
-              <a:t>10/6/2026</a:t>
+              <a:t>10/7/2026</a:t>
             </a:fld>
             <a:endParaRPr lang="en-US"/>
           </a:p>
@@ -2705,7 +2721,7 @@
           <a:p>
             <a:fld id="{C8414FAB-7AD7-4C12-87C1-271A81F50A84}" type="datetimeFigureOut">
               <a:rPr lang="en-US" smtClean="0"/>
-              <a:t>10/6/2026</a:t>
+              <a:t>10/7/2026</a:t>
             </a:fld>
             <a:endParaRPr lang="en-US"/>
           </a:p>
@@ -3603,6 +3619,72 @@
 </p:sld>
 </file>
 
+<file path=ppt/slides/slide4.xml><?xml version="1.0" encoding="utf-8"?>
+<p:sld xmlns:a="http://schemas.openxmlformats.org/drawingml/2006/main" xmlns:r="http://schemas.openxmlformats.org/officeDocument/2006/relationships" xmlns:p="http://schemas.openxmlformats.org/presentationml/2006/main">
+  <p:cSld>
+    <p:spTree>
+      <p:nvGrpSpPr>
+        <p:cNvPr id="1" name="">
+          <a:extLst>
+            <a:ext uri="{FF2B5EF4-FFF2-40B4-BE49-F238E27FC236}">
+              <a16:creationId xmlns:a16="http://schemas.microsoft.com/office/drawing/2014/main" id="{CD80A999-40AC-A66C-A220-70C33747729B}"/>
+            </a:ext>
+          </a:extLst>
+        </p:cNvPr>
+        <p:cNvGrpSpPr/>
+        <p:nvPr/>
+      </p:nvGrpSpPr>
+      <p:grpSpPr>
+        <a:xfrm>
+          <a:off x="0" y="0"/>
+          <a:ext cx="0" cy="0"/>
+          <a:chOff x="0" y="0"/>
+          <a:chExt cx="0" cy="0"/>
+        </a:xfrm>
+      </p:grpSpPr>
+      <p:pic>
+        <p:nvPicPr>
+          <p:cNvPr id="3" name="Immagine 2">
+            <a:extLst>
+              <a:ext uri="{FF2B5EF4-FFF2-40B4-BE49-F238E27FC236}">
+                <a16:creationId xmlns:a16="http://schemas.microsoft.com/office/drawing/2014/main" id="{F251D190-2DFB-2C1B-41F6-CE31AB87266C}"/>
+              </a:ext>
+            </a:extLst>
+          </p:cNvPr>
+          <p:cNvPicPr>
+            <a:picLocks noChangeAspect="1"/>
+          </p:cNvPicPr>
+          <p:nvPr/>
+        </p:nvPicPr>
+        <p:blipFill>
+          <a:blip r:embed="rId2"/>
+          <a:stretch>
+            <a:fillRect/>
+          </a:stretch>
+        </p:blipFill>
+        <p:spPr>
+          <a:xfrm>
+            <a:off x="-9953" y="1269242"/>
+            <a:ext cx="6903786" cy="7888405"/>
+          </a:xfrm>
+          <a:prstGeom prst="rect">
+            <a:avLst/>
+          </a:prstGeom>
+        </p:spPr>
+      </p:pic>
+    </p:spTree>
+    <p:extLst>
+      <p:ext uri="{BB962C8B-B14F-4D97-AF65-F5344CB8AC3E}">
+        <p14:creationId xmlns:p14="http://schemas.microsoft.com/office/powerpoint/2010/main" val="1469452970"/>
+      </p:ext>
+    </p:extLst>
+  </p:cSld>
+  <p:clrMapOvr>
+    <a:masterClrMapping/>
+  </p:clrMapOvr>
+</p:sld>
+</file>
+
 <file path=ppt/theme/theme1.xml><?xml version="1.0" encoding="utf-8"?>
 <a:theme xmlns:a="http://schemas.openxmlformats.org/drawingml/2006/main" name="Tema di Office">
   <a:themeElements>

</xml_diff>